<commit_message>
Fix session 2 volume image continuity
</commit_message>
<xml_diff>
--- a/slides/docker-session2-flask-volume.pptx
+++ b/slides/docker-session2-flask-volume.pptx
@@ -19346,7 +19346,7 @@
                 <a:ea typeface="Aptos Display"/>
                 <a:cs typeface="Aptos Display"/>
               </a:rPr>
-              <a:t>唯讀掛載避免容器改到設定檔</a:t>
+              <a:t>唯讀掛載避免容器改到宿主機檔案</a:t>
             </a:r>
           </a:p>
         </p:txBody>
@@ -19542,7 +19542,7 @@
                 <a:ea typeface="Consolas"/>
                 <a:cs typeface="Consolas"/>
               </a:rPr>
-              <a:t>docker run -v "C:\my-config:/app/config:ro" my-image</a:t>
+              <a:t>docker run --rm -p 8081:80 -v "C:\docker-lab\site:/usr/share/nginx/html:ro" nginx</a:t>
             </a:r>
           </a:p>
         </p:txBody>
@@ -19872,7 +19872,7 @@
                 <a:ea typeface="Aptos"/>
                 <a:cs typeface="Aptos"/>
               </a:rPr>
-              <a:t>掛載設定檔、憑證、只讀資料集，避免程式意外覆寫宿主機檔案。</a:t>
+              <a:t>掛載靜態網頁、設定檔或只讀資料集，避免程式意外覆寫宿主機檔案。</a:t>
             </a:r>
           </a:p>
         </p:txBody>
@@ -20721,7 +20721,7 @@
                 <a:ea typeface="Aptos"/>
                 <a:cs typeface="Aptos"/>
               </a:rPr>
-              <a:t>適合搭配講義附錄的唯讀掛載指令操作。</a:t>
+              <a:t>適合搭配前面的唯讀掛載概念操作。</a:t>
             </a:r>
           </a:p>
         </p:txBody>
@@ -22232,7 +22232,7 @@
                 <a:ea typeface="Consolas"/>
                 <a:cs typeface="Consolas"/>
               </a:rPr>
-              <a:t>docker run -d --name volume-demo -p 8080:80 \</a:t>
+              <a:t>docker run -d --name nginx-bind -p 8080:80 \</a:t>
             </a:r>
           </a:p>
           <a:p>
@@ -24508,7 +24508,7 @@
                 <a:ea typeface="Consolas"/>
                 <a:cs typeface="Consolas"/>
               </a:rPr>
-              <a:t>docker rm -f nginx-life volume-demo</a:t>
+              <a:t>docker rm -f nginx-life nginx-bind</a:t>
             </a:r>
           </a:p>
           <a:p>
@@ -26594,7 +26594,7 @@
                 <a:ea typeface="Aptos Display"/>
                 <a:cs typeface="Aptos Display"/>
               </a:rPr>
-              <a:t>Flask</a:t>
+              <a:t>Volume</a:t>
             </a:r>
           </a:p>
         </p:txBody>
@@ -26924,7 +26924,7 @@
                 <a:ea typeface="Aptos Display"/>
                 <a:cs typeface="Aptos Display"/>
               </a:rPr>
-              <a:t>Volume</a:t>
+              <a:t>Flask</a:t>
             </a:r>
           </a:p>
         </p:txBody>
@@ -27654,7 +27654,7 @@
                 <a:ea typeface="Consolas"/>
                 <a:cs typeface="Consolas"/>
               </a:rPr>
-              <a:t>docker run -d --name volume-demo -p 8080:80 -v "C:\docker-lab\volume-test:/usr/share/nginx/</a:t>
+              <a:t>docker run -d --name nginx-bind -p 8080:80 -v "C:\docker-lab\volume-test:/usr/share/nginx/</a:t>
             </a:r>
           </a:p>
           <a:p>
@@ -27693,7 +27693,7 @@
                 <a:ea typeface="Consolas"/>
                 <a:cs typeface="Consolas"/>
               </a:rPr>
-              <a:t>docker exec -it volume-demo sh</a:t>
+              <a:t>docker exec -it nginx-bind sh</a:t>
             </a:r>
           </a:p>
           <a:p>

</xml_diff>

<commit_message>
Clarify bind mount nginx warm-up
</commit_message>
<xml_diff>
--- a/slides/docker-session2-flask-volume.pptx
+++ b/slides/docker-session2-flask-volume.pptx
@@ -20967,7 +20967,7 @@
                 <a:ea typeface="Aptos"/>
                 <a:cs typeface="Aptos"/>
               </a:rPr>
-              <a:t>VOLUME SYNC LAB</a:t>
+              <a:t>BIND MOUNT WARM-UP</a:t>
             </a:r>
           </a:p>
         </p:txBody>
@@ -21029,7 +21029,7 @@
                 <a:ea typeface="Aptos Display"/>
                 <a:cs typeface="Aptos Display"/>
               </a:rPr>
-              <a:t>實作：Nginx + Bind Mount 同步網頁</a:t>
+              <a:t>暖身：比較 Nginx 有沒有 -v</a:t>
             </a:r>
           </a:p>
         </p:txBody>
@@ -21516,7 +21516,7 @@
                 <a:ea typeface="Aptos"/>
                 <a:cs typeface="Aptos"/>
               </a:rPr>
-              <a:t>寫入 Hello Volume 內容</a:t>
+              <a:t>寫入一行 HTML</a:t>
             </a:r>
           </a:p>
         </p:txBody>
@@ -21714,7 +21714,7 @@
                 <a:ea typeface="Aptos Display"/>
                 <a:cs typeface="Aptos Display"/>
               </a:rPr>
-              <a:t>啟動 Nginx</a:t>
+              <a:t>用官方 Nginx 讀資料夾</a:t>
             </a:r>
           </a:p>
         </p:txBody>
@@ -21974,7 +21974,7 @@
                 <a:ea typeface="Aptos Display"/>
                 <a:cs typeface="Aptos Display"/>
               </a:rPr>
-              <a:t>修改宿主機檔案</a:t>
+              <a:t>只觀察同步</a:t>
             </a:r>
           </a:p>
         </p:txBody>
@@ -22036,7 +22036,7 @@
                 <a:ea typeface="Aptos"/>
                 <a:cs typeface="Aptos"/>
               </a:rPr>
-              <a:t>瀏覽器 F5 馬上看到變更</a:t>
+              <a:t>有 -v 才會讀本機檔案</a:t>
             </a:r>
           </a:p>
         </p:txBody>
@@ -24508,7 +24508,7 @@
                 <a:ea typeface="Consolas"/>
                 <a:cs typeface="Consolas"/>
               </a:rPr>
-              <a:t>docker rm -f nginx-life nginx-bind</a:t>
+              <a:t>docker rm -f nginx-life nginx-default nginx-bind</a:t>
             </a:r>
           </a:p>
           <a:p>
@@ -27385,7 +27385,7 @@
 
 <file path=ppt/slides/slide31.xml><?xml version="1.0" encoding="utf-8"?>
 <p:sld xmlns:a="http://schemas.openxmlformats.org/drawingml/2006/main" xmlns:r="http://schemas.openxmlformats.org/officeDocument/2006/relationships" xmlns:p="http://schemas.openxmlformats.org/presentationml/2006/main">
-  <p:cSld name="範例程式碼：Bind Mount + Nginx">
+  <p:cSld name="範例程式碼：比較 Nginx 有沒有 -v">
     <p:bg>
       <p:bgPr>
         <a:solidFill>
@@ -27481,7 +27481,7 @@
                 <a:ea typeface="Aptos"/>
                 <a:cs typeface="Aptos"/>
               </a:rPr>
-              <a:t>範例程式碼：Bind Mount + Nginx</a:t>
+              <a:t>範例程式碼：比較 Nginx 有沒有 -v</a:t>
             </a:r>
           </a:p>
         </p:txBody>
@@ -27520,7 +27520,7 @@
                 <a:ea typeface="Aptos"/>
                 <a:cs typeface="Aptos"/>
               </a:rPr>
-              <a:t>第 2 堂 | 可直接照做的完整範例</a:t>
+              <a:t>第 2 堂 | 沒有 -v 是預設頁；有 -v 才讀本機資料夾</a:t>
             </a:r>
           </a:p>
         </p:txBody>
@@ -27602,7 +27602,7 @@
                 <a:ea typeface="Consolas"/>
                 <a:cs typeface="Consolas"/>
               </a:rPr>
-              <a:t>mkdir C:\docker-lab\volume-test</a:t>
+              <a:t># 沒有 -v：Nginx 讀 image 內建首頁</a:t>
             </a:r>
           </a:p>
           <a:p>
@@ -27615,7 +27615,7 @@
                 <a:ea typeface="Consolas"/>
                 <a:cs typeface="Consolas"/>
               </a:rPr>
-              <a:t>cd C:\docker-lab\volume-test</a:t>
+              <a:t>docker run -d --name nginx-default -p 8081:80 nginx</a:t>
             </a:r>
           </a:p>
           <a:p>
@@ -27641,7 +27641,7 @@
                 <a:ea typeface="Consolas"/>
                 <a:cs typeface="Consolas"/>
               </a:rPr>
-              <a:t># 建立 index.html 後啟動 Nginx</a:t>
+              <a:t># 有 -v：本機資料夾取代 Nginx 網頁目錄</a:t>
             </a:r>
           </a:p>
           <a:p>
@@ -27654,7 +27654,7 @@
                 <a:ea typeface="Consolas"/>
                 <a:cs typeface="Consolas"/>
               </a:rPr>
-              <a:t>docker run -d --name nginx-bind -p 8080:80 -v "C:\docker-lab\volume-test:/usr/share/nginx/</a:t>
+              <a:t>mkdir C:\docker-lab\volume-test</a:t>
             </a:r>
           </a:p>
           <a:p>
@@ -27667,7 +27667,7 @@
                 <a:ea typeface="Consolas"/>
                 <a:cs typeface="Consolas"/>
               </a:rPr>
-              <a:t>  html" nginx</a:t>
+              <a:t>notepad C:\docker-lab\volume-test\index.html</a:t>
             </a:r>
           </a:p>
           <a:p>
@@ -27693,7 +27693,7 @@
                 <a:ea typeface="Consolas"/>
                 <a:cs typeface="Consolas"/>
               </a:rPr>
-              <a:t>docker exec -it nginx-bind sh</a:t>
+              <a:t>docker run -d --name nginx-bind -p 8080:80 -v "C:\docker-lab\volume-test:/usr/share/nginx/html" nginx</a:t>
             </a:r>
           </a:p>
           <a:p>
@@ -27706,7 +27706,7 @@
                 <a:ea typeface="Consolas"/>
                 <a:cs typeface="Consolas"/>
               </a:rPr>
-              <a:t>cat /usr/share/nginx/html/index.html</a:t>
+              <a:t># 8081 是預設頁；8080 會讀本機 index.html</a:t>
             </a:r>
           </a:p>
           <a:p>
@@ -27719,7 +27719,7 @@
                 <a:ea typeface="Consolas"/>
                 <a:cs typeface="Consolas"/>
               </a:rPr>
-              <a:t>exit</a:t>
+              <a:t>docker rm -f nginx-default nginx-bind</a:t>
             </a:r>
           </a:p>
         </p:txBody>
@@ -31950,7 +31950,7 @@
                 <a:ea typeface="Aptos"/>
                 <a:cs typeface="Aptos"/>
               </a:rPr>
-              <a:t>重點：把程式放在宿主機，讓容器負責提供 Python 執行環境。</a:t>
+              <a:t>剛剛 Nginx 只驗證 -v；現在把同一個概念用在 Flask 專案。</a:t>
             </a:r>
           </a:p>
         </p:txBody>

</xml_diff>

<commit_message>
Add port conflict debugging slide
</commit_message>
<xml_diff>
--- a/slides/docker-session2-flask-volume.pptx
+++ b/slides/docker-session2-flask-volume.pptx
@@ -20,6 +20,7 @@
     <p:sldId id="287" r:id="rId2"/>
     <p:sldId xmlns:r="http://schemas.openxmlformats.org/officeDocument/2006/relationships" id="262" r:id="R7f1e18ea616d4d9c"/>
     <p:sldId xmlns:r="http://schemas.openxmlformats.org/officeDocument/2006/relationships" id="263" r:id="Ra5957e6bea0546d3"/>
+    <p:sldId id="290" r:id="rIdCodexPortDebug35"/>
     <p:sldId xmlns:r="http://schemas.openxmlformats.org/officeDocument/2006/relationships" id="264" r:id="Rec976999b6fc4070"/>
     <p:sldId id="288" r:id="rId3"/>
     <p:sldId xmlns:r="http://schemas.openxmlformats.org/officeDocument/2006/relationships" id="265" r:id="R14a54adb5da94918"/>
@@ -29091,6 +29092,717 @@
 </p:sld>
 </file>
 
+<file path=ppt/slides/slide35.xml><?xml version="1.0" encoding="utf-8"?>
+<p:sld xmlns:a="http://schemas.openxmlformats.org/drawingml/2006/main" xmlns:p="http://schemas.openxmlformats.org/presentationml/2006/main" xmlns:r="http://schemas.openxmlformats.org/officeDocument/2006/relationships">
+  <p:cSld name="Port 被佔用時怎麼查">
+    <p:bg>
+      <p:bgPr>
+        <a:solidFill>
+          <a:srgbClr val="F6F8FB"/>
+        </a:solidFill>
+      </p:bgPr>
+    </p:bg>
+    <p:spTree>
+      <p:nvGrpSpPr>
+        <p:cNvPr id="1" name=""/>
+        <p:cNvGrpSpPr/>
+        <p:nvPr/>
+      </p:nvGrpSpPr>
+      <p:grpSpPr>
+        <a:xfrm/>
+      </p:grpSpPr>
+      <p:sp>
+        <p:nvSpPr>
+          <p:cNvPr id="2" name=""/>
+          <p:cNvSpPr>
+            <a:spLocks noGrp="1"/>
+          </p:cNvSpPr>
+          <p:nvPr/>
+        </p:nvSpPr>
+        <p:spPr>
+          <a:xfrm>
+            <a:off x="609600" y="400050"/>
+            <a:ext cx="6191250" cy="228600"/>
+          </a:xfrm>
+          <a:prstGeom prst="rect">
+            <a:avLst/>
+          </a:prstGeom>
+          <a:noFill/>
+          <a:ln w="0">
+            <a:noFill/>
+            <a:prstDash val="solid"/>
+          </a:ln>
+        </p:spPr>
+        <p:txBody>
+          <a:bodyPr lIns="0" tIns="0" rIns="0" bIns="0" anchor="t">
+            <a:normAutofit fontScale="100000"/>
+          </a:bodyPr>
+          <a:lstStyle/>
+          <a:p>
+            <a:pPr algn="l">
+              <a:lnSpc>
+                <a:spcPct val="106000"/>
+              </a:lnSpc>
+              <a:buNone/>
+              <a:defRPr sz="900" b="1">
+                <a:solidFill>
+                  <a:srgbClr val="0B5CAD"/>
+                </a:solidFill>
+                <a:latin typeface="Aptos"/>
+                <a:ea typeface="Aptos"/>
+                <a:cs typeface="Aptos"/>
+              </a:defRPr>
+            </a:pPr>
+            <a:r>
+              <a:rPr sz="900" b="1">
+                <a:solidFill>
+                  <a:srgbClr val="0B5CAD"/>
+                </a:solidFill>
+                <a:latin typeface="Aptos"/>
+                <a:ea typeface="Aptos"/>
+                <a:cs typeface="Aptos"/>
+              </a:rPr>
+              <a:t>PORT CONFLICT DEBUG</a:t>
+            </a:r>
+          </a:p>
+        </p:txBody>
+      </p:sp>
+      <p:sp>
+        <p:nvSpPr>
+          <p:cNvPr id="3" name=""/>
+          <p:cNvSpPr>
+            <a:spLocks noGrp="1"/>
+          </p:cNvSpPr>
+          <p:nvPr/>
+        </p:nvSpPr>
+        <p:spPr>
+          <a:xfrm>
+            <a:off x="609600" y="742950"/>
+            <a:ext cx="9906000" cy="571500"/>
+          </a:xfrm>
+          <a:prstGeom prst="rect">
+            <a:avLst/>
+          </a:prstGeom>
+          <a:noFill/>
+          <a:ln w="0">
+            <a:noFill/>
+            <a:prstDash val="solid"/>
+          </a:ln>
+        </p:spPr>
+        <p:txBody>
+          <a:bodyPr lIns="0" tIns="0" rIns="0" bIns="0" anchor="t">
+            <a:normAutofit fontScale="100000"/>
+          </a:bodyPr>
+          <a:lstStyle/>
+          <a:p>
+            <a:pPr algn="l">
+              <a:lnSpc>
+                <a:spcPct val="106000"/>
+              </a:lnSpc>
+              <a:buNone/>
+              <a:defRPr sz="2850" b="1">
+                <a:solidFill>
+                  <a:srgbClr val="0B1220"/>
+                </a:solidFill>
+                <a:latin typeface="Aptos Display"/>
+                <a:ea typeface="Aptos Display"/>
+                <a:cs typeface="Aptos Display"/>
+              </a:defRPr>
+            </a:pPr>
+            <a:r>
+              <a:rPr sz="2850" b="1">
+                <a:solidFill>
+                  <a:srgbClr val="0B1220"/>
+                </a:solidFill>
+                <a:latin typeface="Aptos Display"/>
+                <a:ea typeface="Aptos Display"/>
+                <a:cs typeface="Aptos Display"/>
+              </a:rPr>
+              <a:t>Port 被佔用時怎麼查？</a:t>
+            </a:r>
+          </a:p>
+        </p:txBody>
+      </p:sp>
+      <p:sp>
+        <p:nvSpPr>
+          <p:cNvPr id="4" name=""/>
+          <p:cNvSpPr>
+            <a:spLocks noGrp="1"/>
+          </p:cNvSpPr>
+          <p:nvPr/>
+        </p:nvSpPr>
+        <p:spPr>
+          <a:xfrm>
+            <a:off x="762000" y="1390650"/>
+            <a:ext cx="10210800" cy="838200"/>
+          </a:xfrm>
+          <a:prstGeom prst="roundRect">
+            <a:avLst>
+              <a:gd name="adj" fmla="val 8000"/>
+            </a:avLst>
+          </a:prstGeom>
+          <a:solidFill>
+            <a:srgbClr val="EEF2F7"/>
+          </a:solidFill>
+          <a:ln w="9525">
+            <a:solidFill>
+              <a:srgbClr val="CBD5E1"/>
+            </a:solidFill>
+            <a:prstDash val="solid"/>
+          </a:ln>
+        </p:spPr>
+        <p:txBody>
+          <a:bodyPr lIns="171450" tIns="171450" rIns="171450" bIns="171450" anchor="t">
+            <a:normAutofit fontScale="100000"/>
+          </a:bodyPr>
+          <a:lstStyle/>
+          <a:p>
+            <a:pPr algn="ctr">
+              <a:lnSpc>
+                <a:spcPct val="106000"/>
+              </a:lnSpc>
+              <a:buNone/>
+              <a:defRPr sz="1450" b="1">
+                <a:solidFill>
+                  <a:srgbClr val="0B1220"/>
+                </a:solidFill>
+                <a:latin typeface="Aptos"/>
+                <a:ea typeface="Aptos"/>
+                <a:cs typeface="Aptos"/>
+              </a:defRPr>
+            </a:pPr>
+            <a:r>
+              <a:rPr sz="1450" b="1">
+                <a:solidFill>
+                  <a:srgbClr val="0B1220"/>
+                </a:solidFill>
+                <a:latin typeface="Aptos"/>
+                <a:ea typeface="Aptos"/>
+                <a:cs typeface="Aptos"/>
+              </a:rPr>
+              <a:t>-p 的左邊是主機 port；如果被佔用，可以換成 8081、5001。</a:t>
+            </a:r>
+          </a:p>
+          <a:p>
+            <a:pPr algn="ctr">
+              <a:lnSpc>
+                <a:spcPct val="106000"/>
+              </a:lnSpc>
+              <a:buNone/>
+              <a:defRPr sz="1275" b="0">
+                <a:solidFill>
+                  <a:srgbClr val="334155"/>
+                </a:solidFill>
+                <a:latin typeface="Aptos"/>
+                <a:ea typeface="Aptos"/>
+                <a:cs typeface="Aptos"/>
+              </a:defRPr>
+            </a:pPr>
+            <a:r>
+              <a:rPr sz="1275" b="0">
+                <a:solidFill>
+                  <a:srgbClr val="334155"/>
+                </a:solidFill>
+                <a:latin typeface="Aptos"/>
+                <a:ea typeface="Aptos"/>
+                <a:cs typeface="Aptos"/>
+              </a:rPr>
+              <a:t>-p 的右邊是容器內服務 port，通常照 image 或 app 設定，不先亂改。</a:t>
+            </a:r>
+          </a:p>
+        </p:txBody>
+      </p:sp>
+      <p:sp>
+        <p:nvSpPr>
+          <p:cNvPr id="5" name=""/>
+          <p:cNvSpPr>
+            <a:spLocks noGrp="1"/>
+          </p:cNvSpPr>
+          <p:nvPr/>
+        </p:nvSpPr>
+        <p:spPr>
+          <a:xfrm>
+            <a:off x="762000" y="2514600"/>
+            <a:ext cx="4876800" cy="2133600"/>
+          </a:xfrm>
+          <a:prstGeom prst="roundRect">
+            <a:avLst>
+              <a:gd name="adj" fmla="val 8000"/>
+            </a:avLst>
+          </a:prstGeom>
+          <a:solidFill>
+            <a:srgbClr val="E8F3FF"/>
+          </a:solidFill>
+          <a:ln w="9525">
+            <a:solidFill>
+              <a:srgbClr val="B7DCFF"/>
+            </a:solidFill>
+            <a:prstDash val="solid"/>
+          </a:ln>
+        </p:spPr>
+        <p:txBody>
+          <a:bodyPr lIns="171450" tIns="171450" rIns="171450" bIns="171450" anchor="t">
+            <a:normAutofit fontScale="100000"/>
+          </a:bodyPr>
+          <a:lstStyle/>
+          <a:p>
+            <a:pPr algn="l">
+              <a:lnSpc>
+                <a:spcPct val="106000"/>
+              </a:lnSpc>
+              <a:buNone/>
+              <a:defRPr sz="1800" b="1">
+                <a:solidFill>
+                  <a:srgbClr val="0B5CAD"/>
+                </a:solidFill>
+                <a:latin typeface="Aptos Display"/>
+                <a:ea typeface="Aptos Display"/>
+                <a:cs typeface="Aptos Display"/>
+              </a:defRPr>
+            </a:pPr>
+            <a:r>
+              <a:rPr sz="1800" b="1">
+                <a:solidFill>
+                  <a:srgbClr val="0B5CAD"/>
+                </a:solidFill>
+                <a:latin typeface="Aptos Display"/>
+                <a:ea typeface="Aptos Display"/>
+                <a:cs typeface="Aptos Display"/>
+              </a:rPr>
+              <a:t>Windows</a:t>
+            </a:r>
+          </a:p>
+          <a:p>
+            <a:pPr algn="l">
+              <a:lnSpc>
+                <a:spcPct val="106000"/>
+              </a:lnSpc>
+              <a:buNone/>
+              <a:defRPr sz="1225" b="1">
+                <a:solidFill>
+                  <a:srgbClr val="0B1220"/>
+                </a:solidFill>
+                <a:latin typeface="Consolas"/>
+                <a:ea typeface="Consolas"/>
+                <a:cs typeface="Consolas"/>
+              </a:defRPr>
+            </a:pPr>
+            <a:r>
+              <a:rPr sz="1225" b="1">
+                <a:solidFill>
+                  <a:srgbClr val="0B1220"/>
+                </a:solidFill>
+                <a:latin typeface="Consolas"/>
+                <a:ea typeface="Consolas"/>
+                <a:cs typeface="Consolas"/>
+              </a:rPr>
+              <a:t>netstat -ano | findstr :8080</a:t>
+            </a:r>
+          </a:p>
+          <a:p>
+            <a:pPr algn="l">
+              <a:lnSpc>
+                <a:spcPct val="106000"/>
+              </a:lnSpc>
+              <a:buNone/>
+              <a:defRPr sz="1225" b="1">
+                <a:solidFill>
+                  <a:srgbClr val="0B1220"/>
+                </a:solidFill>
+                <a:latin typeface="Consolas"/>
+                <a:ea typeface="Consolas"/>
+                <a:cs typeface="Consolas"/>
+              </a:defRPr>
+            </a:pPr>
+            <a:r>
+              <a:rPr sz="1225" b="1">
+                <a:solidFill>
+                  <a:srgbClr val="0B1220"/>
+                </a:solidFill>
+                <a:latin typeface="Consolas"/>
+                <a:ea typeface="Consolas"/>
+                <a:cs typeface="Consolas"/>
+              </a:rPr>
+              <a:t>tasklist | findstr &lt;PID&gt;</a:t>
+            </a:r>
+          </a:p>
+          <a:p>
+            <a:pPr algn="l">
+              <a:lnSpc>
+                <a:spcPct val="106000"/>
+              </a:lnSpc>
+              <a:buNone/>
+              <a:defRPr sz="1150" b="0">
+                <a:solidFill>
+                  <a:srgbClr val="334155"/>
+                </a:solidFill>
+                <a:latin typeface="Aptos"/>
+                <a:ea typeface="Aptos"/>
+                <a:cs typeface="Aptos"/>
+              </a:defRPr>
+            </a:pPr>
+            <a:r>
+              <a:rPr sz="1150" b="0">
+                <a:solidFill>
+                  <a:srgbClr val="334155"/>
+                </a:solidFill>
+                <a:latin typeface="Aptos"/>
+                <a:ea typeface="Aptos"/>
+                <a:cs typeface="Aptos"/>
+              </a:rPr>
+              <a:t>必要時用工作管理員依 PID 結束程式。</a:t>
+            </a:r>
+          </a:p>
+        </p:txBody>
+      </p:sp>
+      <p:sp>
+        <p:nvSpPr>
+          <p:cNvPr id="6" name=""/>
+          <p:cNvSpPr>
+            <a:spLocks noGrp="1"/>
+          </p:cNvSpPr>
+          <p:nvPr/>
+        </p:nvSpPr>
+        <p:spPr>
+          <a:xfrm>
+            <a:off x="6400800" y="2514600"/>
+            <a:ext cx="4876800" cy="2133600"/>
+          </a:xfrm>
+          <a:prstGeom prst="roundRect">
+            <a:avLst>
+              <a:gd name="adj" fmla="val 8000"/>
+            </a:avLst>
+          </a:prstGeom>
+          <a:solidFill>
+            <a:srgbClr val="E7F8F2"/>
+          </a:solidFill>
+          <a:ln w="9525">
+            <a:solidFill>
+              <a:srgbClr val="99E6C8"/>
+            </a:solidFill>
+            <a:prstDash val="solid"/>
+          </a:ln>
+        </p:spPr>
+        <p:txBody>
+          <a:bodyPr lIns="171450" tIns="171450" rIns="171450" bIns="171450" anchor="t">
+            <a:normAutofit fontScale="100000"/>
+          </a:bodyPr>
+          <a:lstStyle/>
+          <a:p>
+            <a:pPr algn="l">
+              <a:lnSpc>
+                <a:spcPct val="106000"/>
+              </a:lnSpc>
+              <a:buNone/>
+              <a:defRPr sz="1800" b="1">
+                <a:solidFill>
+                  <a:srgbClr val="047857"/>
+                </a:solidFill>
+                <a:latin typeface="Aptos Display"/>
+                <a:ea typeface="Aptos Display"/>
+                <a:cs typeface="Aptos Display"/>
+              </a:defRPr>
+            </a:pPr>
+            <a:r>
+              <a:rPr sz="1800" b="1">
+                <a:solidFill>
+                  <a:srgbClr val="047857"/>
+                </a:solidFill>
+                <a:latin typeface="Aptos Display"/>
+                <a:ea typeface="Aptos Display"/>
+                <a:cs typeface="Aptos Display"/>
+              </a:rPr>
+              <a:t>macOS</a:t>
+            </a:r>
+          </a:p>
+          <a:p>
+            <a:pPr algn="l">
+              <a:lnSpc>
+                <a:spcPct val="106000"/>
+              </a:lnSpc>
+              <a:buNone/>
+              <a:defRPr sz="1125" b="1">
+                <a:solidFill>
+                  <a:srgbClr val="0B1220"/>
+                </a:solidFill>
+                <a:latin typeface="Consolas"/>
+                <a:ea typeface="Consolas"/>
+                <a:cs typeface="Consolas"/>
+              </a:defRPr>
+            </a:pPr>
+            <a:r>
+              <a:rPr sz="1125" b="1">
+                <a:solidFill>
+                  <a:srgbClr val="0B1220"/>
+                </a:solidFill>
+                <a:latin typeface="Consolas"/>
+                <a:ea typeface="Consolas"/>
+                <a:cs typeface="Consolas"/>
+              </a:rPr>
+              <a:t>lsof -nP -iTCP:8080 -sTCP:LISTEN</a:t>
+            </a:r>
+          </a:p>
+          <a:p>
+            <a:pPr algn="l">
+              <a:lnSpc>
+                <a:spcPct val="106000"/>
+              </a:lnSpc>
+              <a:buNone/>
+              <a:defRPr sz="1225" b="1">
+                <a:solidFill>
+                  <a:srgbClr val="0B1220"/>
+                </a:solidFill>
+                <a:latin typeface="Consolas"/>
+                <a:ea typeface="Consolas"/>
+                <a:cs typeface="Consolas"/>
+              </a:defRPr>
+            </a:pPr>
+            <a:r>
+              <a:rPr sz="1225" b="1">
+                <a:solidFill>
+                  <a:srgbClr val="0B1220"/>
+                </a:solidFill>
+                <a:latin typeface="Consolas"/>
+                <a:ea typeface="Consolas"/>
+                <a:cs typeface="Consolas"/>
+              </a:rPr>
+              <a:t>kill &lt;PID&gt;</a:t>
+            </a:r>
+          </a:p>
+          <a:p>
+            <a:pPr algn="l">
+              <a:lnSpc>
+                <a:spcPct val="106000"/>
+              </a:lnSpc>
+              <a:buNone/>
+              <a:defRPr sz="1150" b="0">
+                <a:solidFill>
+                  <a:srgbClr val="334155"/>
+                </a:solidFill>
+                <a:latin typeface="Aptos"/>
+                <a:ea typeface="Aptos"/>
+                <a:cs typeface="Aptos"/>
+              </a:defRPr>
+            </a:pPr>
+            <a:r>
+              <a:rPr sz="1150" b="0">
+                <a:solidFill>
+                  <a:srgbClr val="334155"/>
+                </a:solidFill>
+                <a:latin typeface="Aptos"/>
+                <a:ea typeface="Aptos"/>
+                <a:cs typeface="Aptos"/>
+              </a:rPr>
+              <a:t>不確定是什麼程式時，先換 host port。</a:t>
+            </a:r>
+          </a:p>
+        </p:txBody>
+      </p:sp>
+      <p:sp>
+        <p:nvSpPr>
+          <p:cNvPr id="7" name=""/>
+          <p:cNvSpPr>
+            <a:spLocks noGrp="1"/>
+          </p:cNvSpPr>
+          <p:nvPr/>
+        </p:nvSpPr>
+        <p:spPr>
+          <a:xfrm>
+            <a:off x="1714500" y="5057775"/>
+            <a:ext cx="8382000" cy="609600"/>
+          </a:xfrm>
+          <a:prstGeom prst="roundRect">
+            <a:avLst>
+              <a:gd name="adj" fmla="val 8000"/>
+            </a:avLst>
+          </a:prstGeom>
+          <a:solidFill>
+            <a:srgbClr val="0B1220"/>
+          </a:solidFill>
+          <a:ln w="9525">
+            <a:solidFill>
+              <a:srgbClr val="1E293B"/>
+            </a:solidFill>
+            <a:prstDash val="solid"/>
+          </a:ln>
+        </p:spPr>
+        <p:txBody>
+          <a:bodyPr lIns="171450" tIns="171450" rIns="171450" bIns="171450" anchor="t">
+            <a:normAutofit fontScale="100000"/>
+          </a:bodyPr>
+          <a:lstStyle/>
+          <a:p>
+            <a:pPr algn="ctr">
+              <a:lnSpc>
+                <a:spcPct val="106000"/>
+              </a:lnSpc>
+              <a:buNone/>
+              <a:defRPr sz="1450" b="1">
+                <a:solidFill>
+                  <a:srgbClr val="FFFFFF"/>
+                </a:solidFill>
+                <a:latin typeface="Consolas"/>
+                <a:ea typeface="Consolas"/>
+                <a:cs typeface="Consolas"/>
+              </a:defRPr>
+            </a:pPr>
+            <a:r>
+              <a:rPr sz="1450" b="1">
+                <a:solidFill>
+                  <a:srgbClr val="FFFFFF"/>
+                </a:solidFill>
+                <a:latin typeface="Consolas"/>
+                <a:ea typeface="Consolas"/>
+                <a:cs typeface="Consolas"/>
+              </a:rPr>
+              <a:t>8080 被佔用時：docker run -d -p 8081:80 nginx</a:t>
+            </a:r>
+          </a:p>
+        </p:txBody>
+      </p:sp>
+      <p:sp>
+        <p:nvSpPr>
+          <p:cNvPr id="40" name=""/>
+          <p:cNvSpPr/>
+          <p:nvPr/>
+        </p:nvSpPr>
+        <p:spPr>
+          <a:xfrm>
+            <a:off x="609600" y="6305550"/>
+            <a:ext cx="9906000" cy="13335"/>
+          </a:xfrm>
+          <a:prstGeom prst="rect">
+            <a:avLst/>
+          </a:prstGeom>
+          <a:solidFill>
+            <a:srgbClr val="D9E2EC"/>
+          </a:solidFill>
+          <a:ln w="0">
+            <a:noFill/>
+            <a:prstDash val="solid"/>
+          </a:ln>
+        </p:spPr>
+      </p:sp>
+      <p:sp>
+        <p:nvSpPr>
+          <p:cNvPr id="41" name=""/>
+          <p:cNvSpPr>
+            <a:spLocks noGrp="1"/>
+          </p:cNvSpPr>
+          <p:nvPr/>
+        </p:nvSpPr>
+        <p:spPr>
+          <a:xfrm>
+            <a:off x="609600" y="6400800"/>
+            <a:ext cx="2762250" cy="171450"/>
+          </a:xfrm>
+          <a:prstGeom prst="rect">
+            <a:avLst/>
+          </a:prstGeom>
+          <a:noFill/>
+          <a:ln w="0">
+            <a:noFill/>
+            <a:prstDash val="solid"/>
+          </a:ln>
+        </p:spPr>
+        <p:txBody>
+          <a:bodyPr lIns="0" tIns="0" rIns="0" bIns="0" anchor="t">
+            <a:normAutofit fontScale="100000"/>
+          </a:bodyPr>
+          <a:lstStyle/>
+          <a:p>
+            <a:pPr algn="l">
+              <a:lnSpc>
+                <a:spcPct val="106000"/>
+              </a:lnSpc>
+              <a:buNone/>
+              <a:defRPr sz="825" b="0">
+                <a:solidFill>
+                  <a:srgbClr val="64748B"/>
+                </a:solidFill>
+                <a:latin typeface="Aptos"/>
+                <a:ea typeface="Aptos"/>
+                <a:cs typeface="Aptos"/>
+              </a:defRPr>
+            </a:pPr>
+            <a:r>
+              <a:rPr sz="825" b="0">
+                <a:solidFill>
+                  <a:srgbClr val="64748B"/>
+                </a:solidFill>
+                <a:latin typeface="Aptos"/>
+                <a:ea typeface="Aptos"/>
+                <a:cs typeface="Aptos"/>
+              </a:rPr>
+              <a:t>Docker 基礎教學 | 第 2 堂</a:t>
+            </a:r>
+          </a:p>
+        </p:txBody>
+      </p:sp>
+      <p:sp>
+        <p:nvSpPr>
+          <p:cNvPr id="42" name=""/>
+          <p:cNvSpPr>
+            <a:spLocks noGrp="1"/>
+          </p:cNvSpPr>
+          <p:nvPr/>
+        </p:nvSpPr>
+        <p:spPr>
+          <a:xfrm>
+            <a:off x="11010900" y="6381750"/>
+            <a:ext cx="571500" cy="190500"/>
+          </a:xfrm>
+          <a:prstGeom prst="rect">
+            <a:avLst/>
+          </a:prstGeom>
+          <a:noFill/>
+          <a:ln w="0">
+            <a:noFill/>
+            <a:prstDash val="solid"/>
+          </a:ln>
+        </p:spPr>
+        <p:txBody>
+          <a:bodyPr lIns="0" tIns="0" rIns="0" bIns="0" anchor="t">
+            <a:normAutofit fontScale="100000"/>
+          </a:bodyPr>
+          <a:lstStyle/>
+          <a:p>
+            <a:pPr algn="r">
+              <a:lnSpc>
+                <a:spcPct val="106000"/>
+              </a:lnSpc>
+              <a:buNone/>
+              <a:defRPr sz="900" b="1">
+                <a:solidFill>
+                  <a:srgbClr val="64748B"/>
+                </a:solidFill>
+                <a:latin typeface="Aptos"/>
+                <a:ea typeface="Aptos"/>
+                <a:cs typeface="Aptos"/>
+              </a:defRPr>
+            </a:pPr>
+            <a:r>
+              <a:rPr sz="900" b="1">
+                <a:solidFill>
+                  <a:srgbClr val="64748B"/>
+                </a:solidFill>
+                <a:latin typeface="Aptos"/>
+                <a:ea typeface="Aptos"/>
+                <a:cs typeface="Aptos"/>
+              </a:rPr>
+              <a:t>13A</a:t>
+            </a:r>
+          </a:p>
+        </p:txBody>
+      </p:sp>
+    </p:spTree>
+  </p:cSld>
+  <p:clrMapOvr>
+    <a:masterClrMapping/>
+  </p:clrMapOvr>
+</p:sld>
+</file>
+
 <file path=ppt/slides/slide4.xml><?xml version="1.0" encoding="utf-8"?>
 <p:sld xmlns:a="http://schemas.openxmlformats.org/drawingml/2006/main" xmlns:ns2="http://schemas.microsoft.com/office/drawing/2014/main" xmlns:ns3="http://schemas.microsoft.com/office/powerpoint/2010/main" xmlns:p="http://schemas.openxmlformats.org/presentationml/2006/main">
   <p:cSld>

</xml_diff>